<commit_message>
Add configurable LLM tuning options via .env and apply black formatting
New env vars: ANTHROPIC_MODEL, ANTHROPIC_MAX_TOKENS, ANTHROPIC_TEMPERATURE,
ANTHROPIC_MAX_RETRIES, ANTHROPIC_RETRY_BACKOFF, ANTHROPIC_CHUNK_THRESHOLD,
ANTHROPIC_CHUNK_SIZE, BOT_ENABLED, SLACK_ALERT_CHANNEL. Agent.py now reads
from config instead of hardcoded constants. Black reformatted all files.

Co-Authored-By: Claude Opus 4.6 <noreply@anthropic.com>
</commit_message>
<xml_diff>
--- a/template/Renessai basic template 10_2025.pptx
+++ b/template/Renessai basic template 10_2025.pptx
@@ -20,31 +20,30 @@
     <p:sldId id="265" r:id="rId15"/>
     <p:sldId id="266" r:id="rId16"/>
     <p:sldId id="267" r:id="rId17"/>
-    <p:sldId id="268" r:id="rId18"/>
   </p:sldIdLst>
   <p:sldSz cy="5143500" cx="9144000"/>
   <p:notesSz cx="6858000" cy="9144000"/>
   <p:embeddedFontLst>
     <p:embeddedFont>
       <p:font typeface="Syne ExtraBold"/>
-      <p:bold r:id="rId19"/>
+      <p:bold r:id="rId18"/>
     </p:embeddedFont>
     <p:embeddedFont>
       <p:font typeface="Syne"/>
-      <p:regular r:id="rId20"/>
-      <p:bold r:id="rId21"/>
+      <p:regular r:id="rId19"/>
+      <p:bold r:id="rId20"/>
     </p:embeddedFont>
     <p:embeddedFont>
       <p:font typeface="Syne Medium"/>
-      <p:regular r:id="rId22"/>
-      <p:bold r:id="rId23"/>
+      <p:regular r:id="rId21"/>
+      <p:bold r:id="rId22"/>
     </p:embeddedFont>
     <p:embeddedFont>
       <p:font typeface="Afacad"/>
-      <p:regular r:id="rId24"/>
-      <p:bold r:id="rId25"/>
-      <p:italic r:id="rId26"/>
-      <p:boldItalic r:id="rId27"/>
+      <p:regular r:id="rId23"/>
+      <p:bold r:id="rId24"/>
+      <p:italic r:id="rId25"/>
+      <p:boldItalic r:id="rId26"/>
     </p:embeddedFont>
   </p:embeddedFontLst>
   <p:defaultTextStyle>
@@ -292,7 +291,7 @@
       </p15:sldGuideLst>
     </p:ext>
     <p:ext uri="GoogleSlidesCustomDataVersion2">
-      <go:slidesCustomData xmlns:go="http://customooxmlschemas.google.com/" r:id="rId28" roundtripDataSignature="AMtx7mhYcaG2aO4EL/ZB9k7eDcu95/WKAQ=="/>
+      <go:slidesCustomData xmlns:go="http://customooxmlschemas.google.com/" r:id="rId27" roundtripDataSignature="AMtx7mgDtsoYnOJYbZN9u4mWILQCA7S8HA=="/>
     </p:ext>
   </p:extLst>
 </p:presentation>
@@ -1275,123 +1274,6 @@
       <p:sp>
         <p:nvSpPr>
           <p:cNvPr id="331" name="Google Shape;331;g3c7a02d2bed_0_40:notes"/>
-          <p:cNvSpPr txBox="1"/>
-          <p:nvPr>
-            <p:ph idx="1" type="body"/>
-          </p:nvPr>
-        </p:nvSpPr>
-        <p:spPr>
-          <a:xfrm>
-            <a:off x="685800" y="4343400"/>
-            <a:ext cx="5486400" cy="4114800"/>
-          </a:xfrm>
-          <a:prstGeom prst="rect">
-            <a:avLst/>
-          </a:prstGeom>
-          <a:noFill/>
-          <a:ln>
-            <a:noFill/>
-          </a:ln>
-        </p:spPr>
-        <p:txBody>
-          <a:bodyPr anchorCtr="0" anchor="t" bIns="91425" lIns="91425" spcFirstLastPara="1" rIns="91425" wrap="square" tIns="91425">
-            <a:noAutofit/>
-          </a:bodyPr>
-          <a:lstStyle/>
-          <a:p>
-            <a:pPr indent="0" lvl="0" marL="0" rtl="0" algn="l">
-              <a:lnSpc>
-                <a:spcPct val="100000"/>
-              </a:lnSpc>
-              <a:spcBef>
-                <a:spcPts val="0"/>
-              </a:spcBef>
-              <a:spcAft>
-                <a:spcPts val="0"/>
-              </a:spcAft>
-              <a:buSzPts val="1100"/>
-              <a:buNone/>
-            </a:pPr>
-            <a:r>
-              <a:t/>
-            </a:r>
-            <a:endParaRPr/>
-          </a:p>
-        </p:txBody>
-      </p:sp>
-    </p:spTree>
-  </p:cSld>
-  <p:clrMapOvr>
-    <a:masterClrMapping/>
-  </p:clrMapOvr>
-</p:notes>
-</file>
-
-<file path=ppt/notesSlides/notesSlide13.xml><?xml version="1.0" encoding="utf-8"?>
-<p:notes xmlns:a="http://schemas.openxmlformats.org/drawingml/2006/main" xmlns:r="http://schemas.openxmlformats.org/officeDocument/2006/relationships" xmlns:mc="http://schemas.openxmlformats.org/markup-compatibility/2006" xmlns:mv="urn:schemas-microsoft-com:mac:vml" xmlns:p="http://schemas.openxmlformats.org/presentationml/2006/main" xmlns:c="http://schemas.openxmlformats.org/drawingml/2006/chart" xmlns:dgm="http://schemas.openxmlformats.org/drawingml/2006/diagram" xmlns:o="urn:schemas-microsoft-com:office:office" xmlns:v="urn:schemas-microsoft-com:vml" xmlns:pvml="urn:schemas-microsoft-com:office:powerpoint" xmlns:com="http://schemas.openxmlformats.org/drawingml/2006/compatibility" xmlns:p14="http://schemas.microsoft.com/office/powerpoint/2010/main" xmlns:p15="http://schemas.microsoft.com/office/powerpoint/2012/main" xmlns:ahyp="http://schemas.microsoft.com/office/drawing/2018/hyperlinkcolor" showMasterPhAnim="0" showMasterSp="0">
-  <p:cSld>
-    <p:spTree>
-      <p:nvGrpSpPr>
-        <p:cNvPr id="335" name="Shape 335"/>
-        <p:cNvGrpSpPr/>
-        <p:nvPr/>
-      </p:nvGrpSpPr>
-      <p:grpSpPr>
-        <a:xfrm>
-          <a:off x="0" y="0"/>
-          <a:ext cx="0" cy="0"/>
-          <a:chOff x="0" y="0"/>
-          <a:chExt cx="0" cy="0"/>
-        </a:xfrm>
-      </p:grpSpPr>
-      <p:sp>
-        <p:nvSpPr>
-          <p:cNvPr id="336" name="Google Shape;336;g3c7a02d2bed_0_45:notes"/>
-          <p:cNvSpPr/>
-          <p:nvPr>
-            <p:ph idx="2" type="sldImg"/>
-          </p:nvPr>
-        </p:nvSpPr>
-        <p:spPr>
-          <a:xfrm>
-            <a:off x="381300" y="685800"/>
-            <a:ext cx="6096000" cy="3429000"/>
-          </a:xfrm>
-          <a:custGeom>
-            <a:rect b="b" l="l" r="r" t="t"/>
-            <a:pathLst>
-              <a:path extrusionOk="0" h="120000" w="120000">
-                <a:moveTo>
-                  <a:pt x="0" y="0"/>
-                </a:moveTo>
-                <a:lnTo>
-                  <a:pt x="120000" y="0"/>
-                </a:lnTo>
-                <a:lnTo>
-                  <a:pt x="120000" y="120000"/>
-                </a:lnTo>
-                <a:lnTo>
-                  <a:pt x="0" y="120000"/>
-                </a:lnTo>
-                <a:close/>
-              </a:path>
-            </a:pathLst>
-          </a:custGeom>
-          <a:noFill/>
-          <a:ln cap="flat" cmpd="sng" w="9525">
-            <a:solidFill>
-              <a:srgbClr val="000000"/>
-            </a:solidFill>
-            <a:prstDash val="solid"/>
-            <a:round/>
-            <a:headEnd len="sm" w="sm" type="none"/>
-            <a:tailEnd len="sm" w="sm" type="none"/>
-          </a:ln>
-        </p:spPr>
-      </p:sp>
-      <p:sp>
-        <p:nvSpPr>
-          <p:cNvPr id="337" name="Google Shape;337;g3c7a02d2bed_0_45:notes"/>
           <p:cNvSpPr txBox="1"/>
           <p:nvPr>
             <p:ph idx="1" type="body"/>
@@ -26498,7 +26380,7 @@
             <a:r>
               <a:t/>
             </a:r>
-            <a:endParaRPr sz="8000"/>
+            <a:endParaRPr sz="2800"/>
           </a:p>
         </p:txBody>
       </p:sp>
@@ -26545,7 +26427,7 @@
             <a:r>
               <a:t/>
             </a:r>
-            <a:endParaRPr/>
+            <a:endParaRPr sz="1800"/>
           </a:p>
         </p:txBody>
       </p:sp>
@@ -26934,130 +26816,6 @@
           <p:cNvSpPr txBox="1"/>
           <p:nvPr>
             <p:ph idx="1" type="body"/>
-          </p:nvPr>
-        </p:nvSpPr>
-        <p:spPr>
-          <a:xfrm>
-            <a:off x="342900" y="1152475"/>
-            <a:ext cx="8458200" cy="3617100"/>
-          </a:xfrm>
-          <a:prstGeom prst="rect">
-            <a:avLst/>
-          </a:prstGeom>
-          <a:noFill/>
-          <a:ln>
-            <a:noFill/>
-          </a:ln>
-        </p:spPr>
-        <p:txBody>
-          <a:bodyPr anchorCtr="0" anchor="t" bIns="91425" lIns="91425" spcFirstLastPara="1" rIns="91425" wrap="square" tIns="91425">
-            <a:normAutofit/>
-          </a:bodyPr>
-          <a:lstStyle/>
-          <a:p>
-            <a:pPr indent="0" lvl="0" marL="0" rtl="0" algn="l">
-              <a:lnSpc>
-                <a:spcPct val="115000"/>
-              </a:lnSpc>
-              <a:spcBef>
-                <a:spcPts val="0"/>
-              </a:spcBef>
-              <a:spcAft>
-                <a:spcPts val="1200"/>
-              </a:spcAft>
-              <a:buSzPts val="1800"/>
-              <a:buNone/>
-            </a:pPr>
-            <a:r>
-              <a:t/>
-            </a:r>
-            <a:endParaRPr>
-              <a:latin typeface="Afacad"/>
-              <a:ea typeface="Afacad"/>
-              <a:cs typeface="Afacad"/>
-              <a:sym typeface="Afacad"/>
-            </a:endParaRPr>
-          </a:p>
-        </p:txBody>
-      </p:sp>
-    </p:spTree>
-  </p:cSld>
-  <p:clrMapOvr>
-    <a:masterClrMapping/>
-  </p:clrMapOvr>
-</p:sld>
-</file>
-
-<file path=ppt/slides/slide13.xml><?xml version="1.0" encoding="utf-8"?>
-<p:sld xmlns:a="http://schemas.openxmlformats.org/drawingml/2006/main" xmlns:r="http://schemas.openxmlformats.org/officeDocument/2006/relationships" xmlns:mc="http://schemas.openxmlformats.org/markup-compatibility/2006" xmlns:mv="urn:schemas-microsoft-com:mac:vml" xmlns:p="http://schemas.openxmlformats.org/presentationml/2006/main" xmlns:c="http://schemas.openxmlformats.org/drawingml/2006/chart" xmlns:dgm="http://schemas.openxmlformats.org/drawingml/2006/diagram" xmlns:o="urn:schemas-microsoft-com:office:office" xmlns:v="urn:schemas-microsoft-com:vml" xmlns:pvml="urn:schemas-microsoft-com:office:powerpoint" xmlns:com="http://schemas.openxmlformats.org/drawingml/2006/compatibility" xmlns:p14="http://schemas.microsoft.com/office/powerpoint/2010/main" xmlns:p15="http://schemas.microsoft.com/office/powerpoint/2012/main" xmlns:ahyp="http://schemas.microsoft.com/office/drawing/2018/hyperlinkcolor">
-  <p:cSld>
-    <p:spTree>
-      <p:nvGrpSpPr>
-        <p:cNvPr id="338" name="Shape 338"/>
-        <p:cNvGrpSpPr/>
-        <p:nvPr/>
-      </p:nvGrpSpPr>
-      <p:grpSpPr>
-        <a:xfrm>
-          <a:off x="0" y="0"/>
-          <a:ext cx="0" cy="0"/>
-          <a:chOff x="0" y="0"/>
-          <a:chExt cx="0" cy="0"/>
-        </a:xfrm>
-      </p:grpSpPr>
-      <p:sp>
-        <p:nvSpPr>
-          <p:cNvPr id="339" name="Google Shape;339;g3c7a02d2bed_0_45"/>
-          <p:cNvSpPr txBox="1"/>
-          <p:nvPr>
-            <p:ph idx="4294967295" type="title"/>
-          </p:nvPr>
-        </p:nvSpPr>
-        <p:spPr>
-          <a:xfrm>
-            <a:off x="342900" y="333875"/>
-            <a:ext cx="8458200" cy="887700"/>
-          </a:xfrm>
-          <a:prstGeom prst="rect">
-            <a:avLst/>
-          </a:prstGeom>
-          <a:noFill/>
-          <a:ln>
-            <a:noFill/>
-          </a:ln>
-        </p:spPr>
-        <p:txBody>
-          <a:bodyPr anchorCtr="0" anchor="ctr" bIns="91425" lIns="91425" spcFirstLastPara="1" rIns="91425" wrap="square" tIns="91425">
-            <a:normAutofit/>
-          </a:bodyPr>
-          <a:lstStyle/>
-          <a:p>
-            <a:pPr indent="0" lvl="0" marL="0" rtl="0" algn="l">
-              <a:lnSpc>
-                <a:spcPct val="100000"/>
-              </a:lnSpc>
-              <a:spcBef>
-                <a:spcPts val="0"/>
-              </a:spcBef>
-              <a:spcAft>
-                <a:spcPts val="0"/>
-              </a:spcAft>
-              <a:buSzPts val="2800"/>
-              <a:buNone/>
-            </a:pPr>
-            <a:r>
-              <a:t/>
-            </a:r>
-            <a:endParaRPr/>
-          </a:p>
-        </p:txBody>
-      </p:sp>
-      <p:sp>
-        <p:nvSpPr>
-          <p:cNvPr id="340" name="Google Shape;340;g3c7a02d2bed_0_45"/>
-          <p:cNvSpPr txBox="1"/>
-          <p:nvPr>
-            <p:ph idx="4294967295" type="body"/>
           </p:nvPr>
         </p:nvSpPr>
         <p:spPr>

</xml_diff>